<commit_message>
Canva import: final 32 PPTX templates (sized overlays, grey rule, 1x logos)
Co-Authored-By: Claude Fable 5.1 <noreply@anthropic.com>
Claude-Session: https://claude.ai/code/session_016RdNFTnCQVE9bkeLv64nYj
</commit_message>
<xml_diff>
--- a/11_Canva/Import_PPTX/Landscape/ADIG_Social_Landscape_Blue_Dark.pptx
+++ b/11_Canva/Import_PPTX/Landscape/ADIG_Social_Landscape_Blue_Dark.pptx
@@ -2688,7 +2688,7 @@
       </p:sp>
       <p:pic>
         <p:nvPicPr>
-          <p:cNvPr id="3" name="Image 0" descr="photo_placeholder">    </p:cNvPr>
+          <p:cNvPr id="3" name="Image 0" descr="photo_700x628">    </p:cNvPr>
           <p:cNvPicPr>
             <a:picLocks noChangeAspect="1"/>
           </p:cNvPicPr>
@@ -2702,8 +2702,8 @@
         </p:blipFill>
         <p:spPr>
           <a:xfrm>
-            <a:off x="4762500" y="0"/>
-            <a:ext cx="6667500" cy="5981700"/>
+            <a:off x="4629150" y="-133350"/>
+            <a:ext cx="6934200" cy="6248400"/>
           </a:xfrm>
           <a:prstGeom prst="rect">
             <a:avLst/>
@@ -2712,7 +2712,7 @@
       </p:pic>
       <p:pic>
         <p:nvPicPr>
-          <p:cNvPr id="4" name="Image 1" descr="grad_black">    </p:cNvPr>
+          <p:cNvPr id="4" name="Image 1" descr="gradh_700x628">    </p:cNvPr>
           <p:cNvPicPr>
             <a:picLocks noChangeAspect="1"/>
           </p:cNvPicPr>
@@ -2726,8 +2726,8 @@
         </p:blipFill>
         <p:spPr>
           <a:xfrm>
-            <a:off x="4762500" y="0"/>
-            <a:ext cx="6667500" cy="5981700"/>
+            <a:off x="4629150" y="-133350"/>
+            <a:ext cx="6934200" cy="6248400"/>
           </a:xfrm>
           <a:prstGeom prst="rect">
             <a:avLst/>

</xml_diff>

<commit_message>
Landscape templates: fix EN line wrapping into the CTA; centre the left block
Co-Authored-By: Claude Opus 5.5 <noreply@anthropic.com>
Claude-Session: https://claude.ai/code/session_016RdNFTnCQVE9bkeLv64nYj
</commit_message>
<xml_diff>
--- a/11_Canva/Import_PPTX/Landscape/ADIG_Social_Landscape_Blue_Dark.pptx
+++ b/11_Canva/Import_PPTX/Landscape/ADIG_Social_Landscape_Blue_Dark.pptx
@@ -1481,8 +1481,8 @@
         </p:nvSpPr>
         <p:spPr>
           <a:xfrm>
-            <a:off x="457200" y="571500"/>
-            <a:ext cx="3848100" cy="314325"/>
+            <a:off x="457200" y="1276350"/>
+            <a:ext cx="3848100" cy="257175"/>
           </a:xfrm>
           <a:prstGeom prst="rect">
             <a:avLst/>
@@ -1501,7 +1501,7 @@
               <a:buNone/>
             </a:pPr>
             <a:r>
-              <a:rPr lang="en-US" altLang="en-US" sz="1650" dirty="0">
+              <a:rPr lang="en-US" altLang="en-US" sz="1350" dirty="0">
                 <a:solidFill>
                   <a:srgbClr val="FFFFFF">
                     <a:alpha val="75000"/>
@@ -1513,7 +1513,7 @@
               </a:rPr>
               <a:t>Umrah season 1448 — bookings now open</a:t>
             </a:r>
-            <a:endParaRPr lang="en-US" sz="1650" dirty="0"/>
+            <a:endParaRPr lang="en-US" sz="1350" dirty="0"/>
           </a:p>
         </p:txBody>
       </p:sp>
@@ -1525,7 +1525,7 @@
         </p:nvSpPr>
         <p:spPr>
           <a:xfrm>
-            <a:off x="457200" y="1047750"/>
+            <a:off x="457200" y="1733550"/>
             <a:ext cx="2286000" cy="514350"/>
           </a:xfrm>
           <a:prstGeom prst="rect">
@@ -1550,7 +1550,7 @@
         </p:nvSpPr>
         <p:spPr>
           <a:xfrm>
-            <a:off x="457200" y="1181100"/>
+            <a:off x="457200" y="1866900"/>
             <a:ext cx="2286000" cy="271463"/>
           </a:xfrm>
           <a:prstGeom prst="rect">
@@ -1592,7 +1592,7 @@
         </p:nvSpPr>
         <p:spPr>
           <a:xfrm>
-            <a:off x="2438400" y="1905000"/>
+            <a:off x="2438400" y="2590800"/>
             <a:ext cx="1866900" cy="514350"/>
           </a:xfrm>
           <a:prstGeom prst="rect">
@@ -1614,7 +1614,7 @@
         </p:nvSpPr>
         <p:spPr>
           <a:xfrm>
-            <a:off x="2438400" y="2028825"/>
+            <a:off x="2438400" y="2714625"/>
             <a:ext cx="1866900" cy="285750"/>
           </a:xfrm>
           <a:prstGeom prst="rect">
@@ -1656,7 +1656,7 @@
         </p:nvSpPr>
         <p:spPr>
           <a:xfrm>
-            <a:off x="457200" y="1905000"/>
+            <a:off x="457200" y="2590800"/>
             <a:ext cx="1866900" cy="514350"/>
           </a:xfrm>
           <a:prstGeom prst="rect">
@@ -1678,7 +1678,7 @@
         </p:nvSpPr>
         <p:spPr>
           <a:xfrm>
-            <a:off x="457200" y="2028825"/>
+            <a:off x="457200" y="2714625"/>
             <a:ext cx="1866900" cy="285750"/>
           </a:xfrm>
           <a:prstGeom prst="rect">
@@ -1720,7 +1720,7 @@
         </p:nvSpPr>
         <p:spPr>
           <a:xfrm>
-            <a:off x="2438400" y="2533650"/>
+            <a:off x="2438400" y="3219450"/>
             <a:ext cx="1866900" cy="514350"/>
           </a:xfrm>
           <a:prstGeom prst="rect">
@@ -1742,7 +1742,7 @@
         </p:nvSpPr>
         <p:spPr>
           <a:xfrm>
-            <a:off x="2438400" y="2657475"/>
+            <a:off x="2438400" y="3343275"/>
             <a:ext cx="1866900" cy="285750"/>
           </a:xfrm>
           <a:prstGeom prst="rect">
@@ -1784,7 +1784,7 @@
         </p:nvSpPr>
         <p:spPr>
           <a:xfrm>
-            <a:off x="457200" y="2533650"/>
+            <a:off x="457200" y="3219450"/>
             <a:ext cx="1866900" cy="514350"/>
           </a:xfrm>
           <a:prstGeom prst="rect">
@@ -1806,7 +1806,7 @@
         </p:nvSpPr>
         <p:spPr>
           <a:xfrm>
-            <a:off x="457200" y="2657475"/>
+            <a:off x="457200" y="3343275"/>
             <a:ext cx="1866900" cy="285750"/>
           </a:xfrm>
           <a:prstGeom prst="rect">
@@ -1848,7 +1848,7 @@
         </p:nvSpPr>
         <p:spPr>
           <a:xfrm>
-            <a:off x="457200" y="3390900"/>
+            <a:off x="457200" y="4095750"/>
             <a:ext cx="3848100" cy="171450"/>
           </a:xfrm>
           <a:prstGeom prst="rect">
@@ -2209,8 +2209,8 @@
         </p:nvSpPr>
         <p:spPr>
           <a:xfrm>
-            <a:off x="457200" y="571500"/>
-            <a:ext cx="3848100" cy="314325"/>
+            <a:off x="457200" y="1276350"/>
+            <a:ext cx="3848100" cy="257175"/>
           </a:xfrm>
           <a:prstGeom prst="rect">
             <a:avLst/>
@@ -2229,7 +2229,7 @@
               <a:buNone/>
             </a:pPr>
             <a:r>
-              <a:rPr lang="en-US" altLang="en-US" sz="1650" dirty="0">
+              <a:rPr lang="en-US" altLang="en-US" sz="1350" dirty="0">
                 <a:solidFill>
                   <a:srgbClr val="FFFFFF">
                     <a:alpha val="75000"/>
@@ -2241,7 +2241,7 @@
               </a:rPr>
               <a:t>20% off accommodation packages</a:t>
             </a:r>
-            <a:endParaRPr lang="en-US" sz="1650" dirty="0"/>
+            <a:endParaRPr lang="en-US" sz="1350" dirty="0"/>
           </a:p>
         </p:txBody>
       </p:sp>
@@ -2253,7 +2253,7 @@
         </p:nvSpPr>
         <p:spPr>
           <a:xfrm>
-            <a:off x="457200" y="1047750"/>
+            <a:off x="457200" y="1733550"/>
             <a:ext cx="2286000" cy="514350"/>
           </a:xfrm>
           <a:prstGeom prst="rect">
@@ -2278,7 +2278,7 @@
         </p:nvSpPr>
         <p:spPr>
           <a:xfrm>
-            <a:off x="457200" y="1181100"/>
+            <a:off x="457200" y="1866900"/>
             <a:ext cx="2286000" cy="271463"/>
           </a:xfrm>
           <a:prstGeom prst="rect">
@@ -2320,7 +2320,7 @@
         </p:nvSpPr>
         <p:spPr>
           <a:xfrm>
-            <a:off x="2438400" y="1905000"/>
+            <a:off x="2438400" y="2590800"/>
             <a:ext cx="1866900" cy="514350"/>
           </a:xfrm>
           <a:prstGeom prst="rect">
@@ -2342,7 +2342,7 @@
         </p:nvSpPr>
         <p:spPr>
           <a:xfrm>
-            <a:off x="2438400" y="2028825"/>
+            <a:off x="2438400" y="2714625"/>
             <a:ext cx="1866900" cy="285750"/>
           </a:xfrm>
           <a:prstGeom prst="rect">
@@ -2384,7 +2384,7 @@
         </p:nvSpPr>
         <p:spPr>
           <a:xfrm>
-            <a:off x="457200" y="1905000"/>
+            <a:off x="457200" y="2590800"/>
             <a:ext cx="1866900" cy="514350"/>
           </a:xfrm>
           <a:prstGeom prst="rect">
@@ -2406,7 +2406,7 @@
         </p:nvSpPr>
         <p:spPr>
           <a:xfrm>
-            <a:off x="457200" y="2028825"/>
+            <a:off x="457200" y="2714625"/>
             <a:ext cx="1866900" cy="285750"/>
           </a:xfrm>
           <a:prstGeom prst="rect">
@@ -2448,7 +2448,7 @@
         </p:nvSpPr>
         <p:spPr>
           <a:xfrm>
-            <a:off x="2438400" y="2533650"/>
+            <a:off x="2438400" y="3219450"/>
             <a:ext cx="1866900" cy="514350"/>
           </a:xfrm>
           <a:prstGeom prst="rect">
@@ -2470,7 +2470,7 @@
         </p:nvSpPr>
         <p:spPr>
           <a:xfrm>
-            <a:off x="2438400" y="2657475"/>
+            <a:off x="2438400" y="3343275"/>
             <a:ext cx="1866900" cy="285750"/>
           </a:xfrm>
           <a:prstGeom prst="rect">
@@ -2512,7 +2512,7 @@
         </p:nvSpPr>
         <p:spPr>
           <a:xfrm>
-            <a:off x="457200" y="2533650"/>
+            <a:off x="457200" y="3219450"/>
             <a:ext cx="1866900" cy="514350"/>
           </a:xfrm>
           <a:prstGeom prst="rect">
@@ -2534,7 +2534,7 @@
         </p:nvSpPr>
         <p:spPr>
           <a:xfrm>
-            <a:off x="457200" y="2657475"/>
+            <a:off x="457200" y="3343275"/>
             <a:ext cx="1866900" cy="285750"/>
           </a:xfrm>
           <a:prstGeom prst="rect">
@@ -2576,7 +2576,7 @@
         </p:nvSpPr>
         <p:spPr>
           <a:xfrm>
-            <a:off x="457200" y="3390900"/>
+            <a:off x="457200" y="4095750"/>
             <a:ext cx="3848100" cy="171450"/>
           </a:xfrm>
           <a:prstGeom prst="rect">
@@ -2917,8 +2917,8 @@
         </p:nvSpPr>
         <p:spPr>
           <a:xfrm>
-            <a:off x="457200" y="571500"/>
-            <a:ext cx="3848100" cy="314325"/>
+            <a:off x="457200" y="1276350"/>
+            <a:ext cx="3848100" cy="257175"/>
           </a:xfrm>
           <a:prstGeom prst="rect">
             <a:avLst/>
@@ -2937,7 +2937,7 @@
               <a:buNone/>
             </a:pPr>
             <a:r>
-              <a:rPr lang="en-US" altLang="en-US" sz="1650" dirty="0">
+              <a:rPr lang="en-US" altLang="en-US" sz="1350" dirty="0">
                 <a:solidFill>
                   <a:srgbClr val="FFFFFF">
                     <a:alpha val="75000"/>
@@ -2949,7 +2949,7 @@
               </a:rPr>
               <a:t>Suites in the heart of Makkah</a:t>
             </a:r>
-            <a:endParaRPr lang="en-US" sz="1650" dirty="0"/>
+            <a:endParaRPr lang="en-US" sz="1350" dirty="0"/>
           </a:p>
         </p:txBody>
       </p:sp>
@@ -2961,7 +2961,7 @@
         </p:nvSpPr>
         <p:spPr>
           <a:xfrm>
-            <a:off x="457200" y="1047750"/>
+            <a:off x="457200" y="1733550"/>
             <a:ext cx="2286000" cy="514350"/>
           </a:xfrm>
           <a:prstGeom prst="rect">
@@ -2986,7 +2986,7 @@
         </p:nvSpPr>
         <p:spPr>
           <a:xfrm>
-            <a:off x="457200" y="1181100"/>
+            <a:off x="457200" y="1866900"/>
             <a:ext cx="2286000" cy="271463"/>
           </a:xfrm>
           <a:prstGeom prst="rect">
@@ -3028,7 +3028,7 @@
         </p:nvSpPr>
         <p:spPr>
           <a:xfrm>
-            <a:off x="2438400" y="1905000"/>
+            <a:off x="2438400" y="2590800"/>
             <a:ext cx="1866900" cy="514350"/>
           </a:xfrm>
           <a:prstGeom prst="rect">
@@ -3050,7 +3050,7 @@
         </p:nvSpPr>
         <p:spPr>
           <a:xfrm>
-            <a:off x="2438400" y="2028825"/>
+            <a:off x="2438400" y="2714625"/>
             <a:ext cx="1866900" cy="285750"/>
           </a:xfrm>
           <a:prstGeom prst="rect">
@@ -3092,7 +3092,7 @@
         </p:nvSpPr>
         <p:spPr>
           <a:xfrm>
-            <a:off x="457200" y="1905000"/>
+            <a:off x="457200" y="2590800"/>
             <a:ext cx="1866900" cy="514350"/>
           </a:xfrm>
           <a:prstGeom prst="rect">
@@ -3114,7 +3114,7 @@
         </p:nvSpPr>
         <p:spPr>
           <a:xfrm>
-            <a:off x="457200" y="2028825"/>
+            <a:off x="457200" y="2714625"/>
             <a:ext cx="1866900" cy="285750"/>
           </a:xfrm>
           <a:prstGeom prst="rect">
@@ -3156,7 +3156,7 @@
         </p:nvSpPr>
         <p:spPr>
           <a:xfrm>
-            <a:off x="2438400" y="2533650"/>
+            <a:off x="2438400" y="3219450"/>
             <a:ext cx="1866900" cy="514350"/>
           </a:xfrm>
           <a:prstGeom prst="rect">
@@ -3178,7 +3178,7 @@
         </p:nvSpPr>
         <p:spPr>
           <a:xfrm>
-            <a:off x="2438400" y="2657475"/>
+            <a:off x="2438400" y="3343275"/>
             <a:ext cx="1866900" cy="285750"/>
           </a:xfrm>
           <a:prstGeom prst="rect">
@@ -3220,7 +3220,7 @@
         </p:nvSpPr>
         <p:spPr>
           <a:xfrm>
-            <a:off x="457200" y="2533650"/>
+            <a:off x="457200" y="3219450"/>
             <a:ext cx="1866900" cy="514350"/>
           </a:xfrm>
           <a:prstGeom prst="rect">
@@ -3242,7 +3242,7 @@
         </p:nvSpPr>
         <p:spPr>
           <a:xfrm>
-            <a:off x="457200" y="2657475"/>
+            <a:off x="457200" y="3343275"/>
             <a:ext cx="1866900" cy="285750"/>
           </a:xfrm>
           <a:prstGeom prst="rect">
@@ -3284,7 +3284,7 @@
         </p:nvSpPr>
         <p:spPr>
           <a:xfrm>
-            <a:off x="457200" y="3390900"/>
+            <a:off x="457200" y="4095750"/>
             <a:ext cx="3848100" cy="171450"/>
           </a:xfrm>
           <a:prstGeom prst="rect">

</xml_diff>